<commit_message>
Update Report with Conclusion
</commit_message>
<xml_diff>
--- a/docs/Report.pptx
+++ b/docs/Report.pptx
@@ -243,7 +243,7 @@
           <a:p>
             <a:fld id="{643FB994-8C7A-432F-9145-2B89982E5304}" type="datetimeFigureOut">
               <a:rPr lang="zh-TW" altLang="en-US" smtClean="0"/>
-              <a:t>2026/5/6</a:t>
+              <a:t>2026/5/7</a:t>
             </a:fld>
             <a:endParaRPr lang="zh-TW" altLang="en-US"/>
           </a:p>
@@ -413,7 +413,7 @@
           <a:p>
             <a:fld id="{643FB994-8C7A-432F-9145-2B89982E5304}" type="datetimeFigureOut">
               <a:rPr lang="zh-TW" altLang="en-US" smtClean="0"/>
-              <a:t>2026/5/6</a:t>
+              <a:t>2026/5/7</a:t>
             </a:fld>
             <a:endParaRPr lang="zh-TW" altLang="en-US"/>
           </a:p>
@@ -593,7 +593,7 @@
           <a:p>
             <a:fld id="{643FB994-8C7A-432F-9145-2B89982E5304}" type="datetimeFigureOut">
               <a:rPr lang="zh-TW" altLang="en-US" smtClean="0"/>
-              <a:t>2026/5/6</a:t>
+              <a:t>2026/5/7</a:t>
             </a:fld>
             <a:endParaRPr lang="zh-TW" altLang="en-US"/>
           </a:p>
@@ -763,7 +763,7 @@
           <a:p>
             <a:fld id="{643FB994-8C7A-432F-9145-2B89982E5304}" type="datetimeFigureOut">
               <a:rPr lang="zh-TW" altLang="en-US" smtClean="0"/>
-              <a:t>2026/5/6</a:t>
+              <a:t>2026/5/7</a:t>
             </a:fld>
             <a:endParaRPr lang="zh-TW" altLang="en-US"/>
           </a:p>
@@ -1009,7 +1009,7 @@
           <a:p>
             <a:fld id="{643FB994-8C7A-432F-9145-2B89982E5304}" type="datetimeFigureOut">
               <a:rPr lang="zh-TW" altLang="en-US" smtClean="0"/>
-              <a:t>2026/5/6</a:t>
+              <a:t>2026/5/7</a:t>
             </a:fld>
             <a:endParaRPr lang="zh-TW" altLang="en-US"/>
           </a:p>
@@ -1241,7 +1241,7 @@
           <a:p>
             <a:fld id="{643FB994-8C7A-432F-9145-2B89982E5304}" type="datetimeFigureOut">
               <a:rPr lang="zh-TW" altLang="en-US" smtClean="0"/>
-              <a:t>2026/5/6</a:t>
+              <a:t>2026/5/7</a:t>
             </a:fld>
             <a:endParaRPr lang="zh-TW" altLang="en-US"/>
           </a:p>
@@ -1608,7 +1608,7 @@
           <a:p>
             <a:fld id="{643FB994-8C7A-432F-9145-2B89982E5304}" type="datetimeFigureOut">
               <a:rPr lang="zh-TW" altLang="en-US" smtClean="0"/>
-              <a:t>2026/5/6</a:t>
+              <a:t>2026/5/7</a:t>
             </a:fld>
             <a:endParaRPr lang="zh-TW" altLang="en-US"/>
           </a:p>
@@ -1726,7 +1726,7 @@
           <a:p>
             <a:fld id="{643FB994-8C7A-432F-9145-2B89982E5304}" type="datetimeFigureOut">
               <a:rPr lang="zh-TW" altLang="en-US" smtClean="0"/>
-              <a:t>2026/5/6</a:t>
+              <a:t>2026/5/7</a:t>
             </a:fld>
             <a:endParaRPr lang="zh-TW" altLang="en-US"/>
           </a:p>
@@ -1821,7 +1821,7 @@
           <a:p>
             <a:fld id="{643FB994-8C7A-432F-9145-2B89982E5304}" type="datetimeFigureOut">
               <a:rPr lang="zh-TW" altLang="en-US" smtClean="0"/>
-              <a:t>2026/5/6</a:t>
+              <a:t>2026/5/7</a:t>
             </a:fld>
             <a:endParaRPr lang="zh-TW" altLang="en-US"/>
           </a:p>
@@ -2098,7 +2098,7 @@
           <a:p>
             <a:fld id="{643FB994-8C7A-432F-9145-2B89982E5304}" type="datetimeFigureOut">
               <a:rPr lang="zh-TW" altLang="en-US" smtClean="0"/>
-              <a:t>2026/5/6</a:t>
+              <a:t>2026/5/7</a:t>
             </a:fld>
             <a:endParaRPr lang="zh-TW" altLang="en-US"/>
           </a:p>
@@ -2355,7 +2355,7 @@
           <a:p>
             <a:fld id="{643FB994-8C7A-432F-9145-2B89982E5304}" type="datetimeFigureOut">
               <a:rPr lang="zh-TW" altLang="en-US" smtClean="0"/>
-              <a:t>2026/5/6</a:t>
+              <a:t>2026/5/7</a:t>
             </a:fld>
             <a:endParaRPr lang="zh-TW" altLang="en-US"/>
           </a:p>
@@ -2568,7 +2568,7 @@
           <a:p>
             <a:fld id="{643FB994-8C7A-432F-9145-2B89982E5304}" type="datetimeFigureOut">
               <a:rPr lang="zh-TW" altLang="en-US" smtClean="0"/>
-              <a:t>2026/5/6</a:t>
+              <a:t>2026/5/7</a:t>
             </a:fld>
             <a:endParaRPr lang="zh-TW" altLang="en-US"/>
           </a:p>
@@ -2987,10 +2987,10 @@
         </p:nvGrpSpPr>
         <p:grpSpPr>
           <a:xfrm>
-            <a:off x="10937797" y="12065713"/>
-            <a:ext cx="1813156" cy="1486293"/>
-            <a:chOff x="11452052" y="9350311"/>
-            <a:chExt cx="2602438" cy="2066339"/>
+            <a:off x="10740633" y="12024142"/>
+            <a:ext cx="2062650" cy="1527861"/>
+            <a:chOff x="11169062" y="9292519"/>
+            <a:chExt cx="2960539" cy="2124130"/>
           </a:xfrm>
         </p:grpSpPr>
         <p:grpSp>
@@ -3007,10 +3007,10 @@
           </p:nvGrpSpPr>
           <p:grpSpPr>
             <a:xfrm>
-              <a:off x="11452052" y="9350311"/>
-              <a:ext cx="2369088" cy="2066339"/>
-              <a:chOff x="13531736" y="8046847"/>
-              <a:chExt cx="2369088" cy="1661086"/>
+              <a:off x="11452052" y="9292519"/>
+              <a:ext cx="2369088" cy="2124130"/>
+              <a:chOff x="13531736" y="8000390"/>
+              <a:chExt cx="2369088" cy="1707543"/>
             </a:xfrm>
           </p:grpSpPr>
           <p:pic>
@@ -3036,7 +3036,7 @@
             </p:blipFill>
             <p:spPr>
               <a:xfrm>
-                <a:off x="14173254" y="8046847"/>
+                <a:off x="14158066" y="8000390"/>
                 <a:ext cx="1110501" cy="577138"/>
               </a:xfrm>
               <a:prstGeom prst="rect">
@@ -3719,8 +3719,8 @@
           </p:nvSpPr>
           <p:spPr>
             <a:xfrm>
-              <a:off x="11650996" y="10068253"/>
-              <a:ext cx="2403494" cy="599046"/>
+              <a:off x="11169062" y="10109367"/>
+              <a:ext cx="2960539" cy="599046"/>
             </a:xfrm>
             <a:prstGeom prst="rect">
               <a:avLst/>
@@ -3739,7 +3739,7 @@
                   <a:ea typeface="標楷體" panose="03000509000000000000" pitchFamily="65" charset="-120"/>
                   <a:cs typeface="Times New Roman" panose="02020603050405020304" pitchFamily="18" charset="0"/>
                 </a:rPr>
-                <a:t>Probe flow</a:t>
+                <a:t>Probing Packets</a:t>
               </a:r>
               <a:endParaRPr lang="zh-TW" altLang="en-US" sz="2200" dirty="0"/>
             </a:p>
@@ -3774,8 +3774,8 @@
         </p:blipFill>
         <p:spPr>
           <a:xfrm>
-            <a:off x="14453594" y="13555042"/>
-            <a:ext cx="6423064" cy="4282042"/>
+            <a:off x="14177738" y="13356327"/>
+            <a:ext cx="6742464" cy="4494975"/>
           </a:xfrm>
           <a:prstGeom prst="rect">
             <a:avLst/>
@@ -4542,8 +4542,8 @@
         </p:nvGrpSpPr>
         <p:grpSpPr>
           <a:xfrm>
-            <a:off x="14461155" y="8972873"/>
-            <a:ext cx="6415563" cy="14953184"/>
+            <a:off x="14213307" y="8972873"/>
+            <a:ext cx="6663412" cy="14953184"/>
             <a:chOff x="928686" y="9588372"/>
             <a:chExt cx="6980591" cy="4434809"/>
           </a:xfrm>
@@ -4681,7 +4681,7 @@
         <p:spPr>
           <a:xfrm>
             <a:off x="928683" y="24173877"/>
-            <a:ext cx="19916775" cy="2185214"/>
+            <a:ext cx="19916775" cy="5139869"/>
           </a:xfrm>
           <a:prstGeom prst="rect">
             <a:avLst/>
@@ -4713,7 +4713,7 @@
                 <a:ea typeface="標楷體" panose="03000509000000000000" pitchFamily="65" charset="-120"/>
                 <a:cs typeface="Times New Roman" panose="02020603050405020304" pitchFamily="18" charset="0"/>
               </a:rPr>
-              <a:t> • External schedulers may generate communication schedules, but their feasibility must be verified.</a:t>
+              <a:t> • We built an NS-3-based framework to support link probing, schedule replay, and UAV-to-LEO uplink evaluation in UAV-assisted SAGIN scenarios.</a:t>
             </a:r>
           </a:p>
           <a:p>
@@ -4723,7 +4723,7 @@
                 <a:ea typeface="標楷體" panose="03000509000000000000" pitchFamily="65" charset="-120"/>
                 <a:cs typeface="Times New Roman" panose="02020603050405020304" pitchFamily="18" charset="0"/>
               </a:rPr>
-              <a:t> • We need a framework that can replay task schedules in NS-3 and evaluate communication performance.</a:t>
+              <a:t> • This work does not directly solve the scheduling problem, but provides a simulation and measurement foundation for evaluating scheduler decisions.</a:t>
             </a:r>
           </a:p>
           <a:p>
@@ -4733,7 +4733,27 @@
                 <a:ea typeface="標楷體" panose="03000509000000000000" pitchFamily="65" charset="-120"/>
                 <a:cs typeface="Times New Roman" panose="02020603050405020304" pitchFamily="18" charset="0"/>
               </a:rPr>
-              <a:t> • We also need to estimate or measure link quality for UAV-to-UAV and UAV-to-LEO communication.</a:t>
+              <a:t> • The UAV-to-UAV probing module provides scheduler-ready link information, including SNR, estimated rate, delivery ratio, and measured throughput.</a:t>
+            </a:r>
+          </a:p>
+          <a:p>
+            <a:r>
+              <a:rPr lang="en-US" altLang="zh-TW" sz="3200" dirty="0">
+                <a:latin typeface="Times New Roman" panose="02020603050405020304" pitchFamily="18" charset="0"/>
+                <a:ea typeface="標楷體" panose="03000509000000000000" pitchFamily="65" charset="-120"/>
+                <a:cs typeface="Times New Roman" panose="02020603050405020304" pitchFamily="18" charset="0"/>
+              </a:rPr>
+              <a:t> • The schedule replay engine verifies generated task plans using task completion, finish time, and deadline satisfaction.</a:t>
+            </a:r>
+          </a:p>
+          <a:p>
+            <a:r>
+              <a:rPr lang="en-US" altLang="zh-TW" sz="3200" dirty="0">
+                <a:latin typeface="Times New Roman" panose="02020603050405020304" pitchFamily="18" charset="0"/>
+                <a:ea typeface="標楷體" panose="03000509000000000000" pitchFamily="65" charset="-120"/>
+                <a:cs typeface="Times New Roman" panose="02020603050405020304" pitchFamily="18" charset="0"/>
+              </a:rPr>
+              <a:t> • Future work: integrate scheduler decisions with UAV-to-UAV and UAV-to-LEO simulations for complete end-to-end mission validation.</a:t>
             </a:r>
             <a:endParaRPr lang="zh-TW" altLang="en-US" sz="3200" dirty="0">
               <a:latin typeface="Times New Roman" panose="02020603050405020304" pitchFamily="18" charset="0"/>
@@ -9571,7 +9591,7 @@
         </p:nvSpPr>
         <p:spPr>
           <a:xfrm>
-            <a:off x="14631134" y="18132484"/>
+            <a:off x="14492416" y="18149605"/>
             <a:ext cx="6208932" cy="5262979"/>
           </a:xfrm>
           <a:prstGeom prst="rect">
@@ -9654,9 +9674,9 @@
           <p:nvPr/>
         </p:nvCxnSpPr>
         <p:spPr>
-          <a:xfrm flipV="1">
-            <a:off x="13941479" y="21511534"/>
-            <a:ext cx="313691" cy="4"/>
+          <a:xfrm>
+            <a:off x="13941479" y="21511538"/>
+            <a:ext cx="153503" cy="0"/>
           </a:xfrm>
           <a:prstGeom prst="line">
             <a:avLst/>
@@ -9691,13 +9711,15 @@
               </a:ext>
             </a:extLst>
           </p:cNvPr>
-          <p:cNvCxnSpPr/>
+          <p:cNvCxnSpPr>
+            <a:cxnSpLocks/>
+          </p:cNvCxnSpPr>
           <p:nvPr/>
         </p:nvCxnSpPr>
         <p:spPr>
-          <a:xfrm flipV="1">
-            <a:off x="14240256" y="17337024"/>
-            <a:ext cx="0" cy="4174513"/>
+          <a:xfrm flipH="1" flipV="1">
+            <a:off x="14089856" y="17249775"/>
+            <a:ext cx="5126" cy="4261762"/>
           </a:xfrm>
           <a:prstGeom prst="line">
             <a:avLst/>
@@ -9732,13 +9754,15 @@
               </a:ext>
             </a:extLst>
           </p:cNvPr>
-          <p:cNvCxnSpPr/>
+          <p:cNvCxnSpPr>
+            <a:cxnSpLocks/>
+          </p:cNvCxnSpPr>
           <p:nvPr/>
         </p:nvCxnSpPr>
         <p:spPr>
           <a:xfrm>
-            <a:off x="14225696" y="17337024"/>
-            <a:ext cx="2406396" cy="0"/>
+            <a:off x="14077950" y="17249775"/>
+            <a:ext cx="2346201" cy="0"/>
           </a:xfrm>
           <a:prstGeom prst="straightConnector1">
             <a:avLst/>
@@ -9781,9 +9805,9 @@
           <p:nvPr/>
         </p:nvCxnSpPr>
         <p:spPr>
-          <a:xfrm>
-            <a:off x="13931846" y="11387392"/>
-            <a:ext cx="308410" cy="0"/>
+          <a:xfrm flipV="1">
+            <a:off x="13931846" y="11387391"/>
+            <a:ext cx="146104" cy="1"/>
           </a:xfrm>
           <a:prstGeom prst="line">
             <a:avLst/>
@@ -9825,8 +9849,8 @@
         </p:nvCxnSpPr>
         <p:spPr>
           <a:xfrm flipV="1">
-            <a:off x="14218671" y="11387391"/>
-            <a:ext cx="2438" cy="3801688"/>
+            <a:off x="14089856" y="11366375"/>
+            <a:ext cx="5126" cy="3713683"/>
           </a:xfrm>
           <a:prstGeom prst="line">
             <a:avLst/>
@@ -9868,8 +9892,8 @@
         </p:nvCxnSpPr>
         <p:spPr>
           <a:xfrm>
-            <a:off x="14225696" y="15189079"/>
-            <a:ext cx="405438" cy="6075"/>
+            <a:off x="14077950" y="15080058"/>
+            <a:ext cx="266700" cy="0"/>
           </a:xfrm>
           <a:prstGeom prst="straightConnector1">
             <a:avLst/>
@@ -10940,7 +10964,7 @@
         <p:spPr>
           <a:xfrm>
             <a:off x="13944119" y="15702016"/>
-            <a:ext cx="4354415" cy="0"/>
+            <a:ext cx="4321994" cy="0"/>
           </a:xfrm>
           <a:prstGeom prst="line">
             <a:avLst/>
@@ -10981,9 +11005,9 @@
           <p:nvPr/>
         </p:nvCxnSpPr>
         <p:spPr>
-          <a:xfrm flipH="1" flipV="1">
-            <a:off x="18295402" y="15696063"/>
-            <a:ext cx="3132" cy="420237"/>
+          <a:xfrm flipV="1">
+            <a:off x="18261407" y="15702016"/>
+            <a:ext cx="0" cy="333440"/>
           </a:xfrm>
           <a:prstGeom prst="line">
             <a:avLst/>
@@ -11025,8 +11049,8 @@
         </p:nvCxnSpPr>
         <p:spPr>
           <a:xfrm>
-            <a:off x="18291951" y="16116300"/>
-            <a:ext cx="268095" cy="0"/>
+            <a:off x="18245950" y="16035456"/>
+            <a:ext cx="301426" cy="0"/>
           </a:xfrm>
           <a:prstGeom prst="straightConnector1">
             <a:avLst/>

</xml_diff>